<commit_message>
docs: strip template scaffolding from the competition deck
- remove the 6 P0 card rule-hint rows (e.g. '<=20 chars') so cards carry
  only real content
- drop the '(示例)' placeholder tag on the scenario slide
- reword TOC item 8 to 'Demo 视频（复赛提交）'
- verified: no template scaffolding residue across all 19 slides
</commit_message>
<xml_diff>
--- a/docs/competition/OpenWorkProof参赛方案/OpenWorkProof初赛方案-官方模板.pptx
+++ b/docs/competition/OpenWorkProof参赛方案/OpenWorkProof初赛方案-官方模板.pptx
@@ -5513,47 +5513,6 @@
       </p:sp>
       <p:sp>
         <p:nvSpPr>
-          <p:cNvPr id="8" name="Text 6"/>
-          <p:cNvSpPr/>
-          <p:nvPr/>
-        </p:nvSpPr>
-        <p:spPr>
-          <a:xfrm>
-            <a:off x="850392" y="2514600"/>
-            <a:ext cx="3027578" cy="548640"/>
-          </a:xfrm>
-          <a:prstGeom prst="rect">
-            <a:avLst/>
-          </a:prstGeom>
-          <a:noFill/>
-        </p:spPr>
-        <p:txBody>
-          <a:bodyPr wrap="square" lIns="0" tIns="0" rIns="0" bIns="0" rtlCol="0" anchor="t"/>
-          <a:lstStyle/>
-          <a:p>
-            <a:pPr marL="0" indent="0">
-              <a:lnSpc>
-                <a:spcPct val="115000"/>
-              </a:lnSpc>
-              <a:buNone/>
-            </a:pPr>
-            <a:r>
-              <a:rPr lang="en-US" sz="1100" dirty="0">
-                <a:solidFill>
-                  <a:srgbClr val="6B7280"/>
-                </a:solidFill>
-                <a:latin typeface="微软雅黑" pitchFamily="34" charset="0"/>
-                <a:ea typeface="微软雅黑" pitchFamily="34" charset="-122"/>
-                <a:cs typeface="微软雅黑" pitchFamily="34" charset="-120"/>
-              </a:rPr>
-              <a:t>≤ 20 字。一句话说清「为谁、解决什么」。</a:t>
-            </a:r>
-            <a:endParaRPr lang="en-US" sz="1100" dirty="0"/>
-          </a:p>
-        </p:txBody>
-      </p:sp>
-      <p:sp>
-        <p:nvSpPr>
           <p:cNvPr id="9" name="Text 7"/>
           <p:cNvSpPr/>
           <p:nvPr/>
@@ -5678,47 +5637,6 @@
       </p:sp>
       <p:sp>
         <p:nvSpPr>
-          <p:cNvPr id="13" name="Text 11"/>
-          <p:cNvSpPr/>
-          <p:nvPr/>
-        </p:nvSpPr>
-        <p:spPr>
-          <a:xfrm>
-            <a:off x="4609490" y="2514600"/>
-            <a:ext cx="3027578" cy="548640"/>
-          </a:xfrm>
-          <a:prstGeom prst="rect">
-            <a:avLst/>
-          </a:prstGeom>
-          <a:noFill/>
-        </p:spPr>
-        <p:txBody>
-          <a:bodyPr wrap="square" lIns="0" tIns="0" rIns="0" bIns="0" rtlCol="0" anchor="t"/>
-          <a:lstStyle/>
-          <a:p>
-            <a:pPr marL="0" indent="0">
-              <a:lnSpc>
-                <a:spcPct val="115000"/>
-              </a:lnSpc>
-              <a:buNone/>
-            </a:pPr>
-            <a:r>
-              <a:rPr lang="en-US" sz="1100" dirty="0">
-                <a:solidFill>
-                  <a:srgbClr val="6B7280"/>
-                </a:solidFill>
-                <a:latin typeface="微软雅黑" pitchFamily="34" charset="0"/>
-                <a:ea typeface="微软雅黑" pitchFamily="34" charset="-122"/>
-                <a:cs typeface="微软雅黑" pitchFamily="34" charset="-120"/>
-              </a:rPr>
-              <a:t>目标用户是谁、在什么场景、现实痛点是什么。</a:t>
-            </a:r>
-            <a:endParaRPr lang="en-US" sz="1100" dirty="0"/>
-          </a:p>
-        </p:txBody>
-      </p:sp>
-      <p:sp>
-        <p:nvSpPr>
           <p:cNvPr id="14" name="Text 12"/>
           <p:cNvSpPr/>
           <p:nvPr/>
@@ -5843,47 +5761,6 @@
       </p:sp>
       <p:sp>
         <p:nvSpPr>
-          <p:cNvPr id="18" name="Text 16"/>
-          <p:cNvSpPr/>
-          <p:nvPr/>
-        </p:nvSpPr>
-        <p:spPr>
-          <a:xfrm>
-            <a:off x="8368589" y="2514600"/>
-            <a:ext cx="3027578" cy="548640"/>
-          </a:xfrm>
-          <a:prstGeom prst="rect">
-            <a:avLst/>
-          </a:prstGeom>
-          <a:noFill/>
-        </p:spPr>
-        <p:txBody>
-          <a:bodyPr wrap="square" lIns="0" tIns="0" rIns="0" bIns="0" rtlCol="0" anchor="t"/>
-          <a:lstStyle/>
-          <a:p>
-            <a:pPr marL="0" indent="0">
-              <a:lnSpc>
-                <a:spcPct val="115000"/>
-              </a:lnSpc>
-              <a:buNone/>
-            </a:pPr>
-            <a:r>
-              <a:rPr lang="en-US" sz="1100" dirty="0">
-                <a:solidFill>
-                  <a:srgbClr val="6B7280"/>
-                </a:solidFill>
-                <a:latin typeface="微软雅黑" pitchFamily="34" charset="0"/>
-                <a:ea typeface="微软雅黑" pitchFamily="34" charset="-122"/>
-                <a:cs typeface="微软雅黑" pitchFamily="34" charset="-120"/>
-              </a:rPr>
-              <a:t>一句话讲清整体思路：用多 Agent + Skill 怎么解。</a:t>
-            </a:r>
-            <a:endParaRPr lang="en-US" sz="1100" dirty="0"/>
-          </a:p>
-        </p:txBody>
-      </p:sp>
-      <p:sp>
-        <p:nvSpPr>
           <p:cNvPr id="19" name="Text 17"/>
           <p:cNvSpPr/>
           <p:nvPr/>
@@ -6008,47 +5885,6 @@
       </p:sp>
       <p:sp>
         <p:nvSpPr>
-          <p:cNvPr id="23" name="Text 21"/>
-          <p:cNvSpPr/>
-          <p:nvPr/>
-        </p:nvSpPr>
-        <p:spPr>
-          <a:xfrm>
-            <a:off x="850392" y="4325112"/>
-            <a:ext cx="3027578" cy="548640"/>
-          </a:xfrm>
-          <a:prstGeom prst="rect">
-            <a:avLst/>
-          </a:prstGeom>
-          <a:noFill/>
-        </p:spPr>
-        <p:txBody>
-          <a:bodyPr wrap="square" lIns="0" tIns="0" rIns="0" bIns="0" rtlCol="0" anchor="t"/>
-          <a:lstStyle/>
-          <a:p>
-            <a:pPr marL="0" indent="0">
-              <a:lnSpc>
-                <a:spcPct val="115000"/>
-              </a:lnSpc>
-              <a:buNone/>
-            </a:pPr>
-            <a:r>
-              <a:rPr lang="en-US" sz="1100" dirty="0">
-                <a:solidFill>
-                  <a:srgbClr val="6B7280"/>
-                </a:solidFill>
-                <a:latin typeface="微软雅黑" pitchFamily="34" charset="0"/>
-                <a:ea typeface="微软雅黑" pitchFamily="34" charset="-122"/>
-                <a:cs typeface="微软雅黑" pitchFamily="34" charset="-120"/>
-              </a:rPr>
-              <a:t>对比现有做法，你独特/更优在哪。</a:t>
-            </a:r>
-            <a:endParaRPr lang="en-US" sz="1100" dirty="0"/>
-          </a:p>
-        </p:txBody>
-      </p:sp>
-      <p:sp>
-        <p:nvSpPr>
           <p:cNvPr id="24" name="Text 22"/>
           <p:cNvSpPr/>
           <p:nvPr/>
@@ -6173,47 +6009,6 @@
       </p:sp>
       <p:sp>
         <p:nvSpPr>
-          <p:cNvPr id="28" name="Text 26"/>
-          <p:cNvSpPr/>
-          <p:nvPr/>
-        </p:nvSpPr>
-        <p:spPr>
-          <a:xfrm>
-            <a:off x="4609490" y="4325112"/>
-            <a:ext cx="3027578" cy="548640"/>
-          </a:xfrm>
-          <a:prstGeom prst="rect">
-            <a:avLst/>
-          </a:prstGeom>
-          <a:noFill/>
-        </p:spPr>
-        <p:txBody>
-          <a:bodyPr wrap="square" lIns="0" tIns="0" rIns="0" bIns="0" rtlCol="0" anchor="t"/>
-          <a:lstStyle/>
-          <a:p>
-            <a:pPr marL="0" indent="0">
-              <a:lnSpc>
-                <a:spcPct val="115000"/>
-              </a:lnSpc>
-              <a:buNone/>
-            </a:pPr>
-            <a:r>
-              <a:rPr lang="en-US" sz="1100" dirty="0">
-                <a:solidFill>
-                  <a:srgbClr val="6B7280"/>
-                </a:solidFill>
-                <a:latin typeface="微软雅黑" pitchFamily="34" charset="0"/>
-                <a:ea typeface="微软雅黑" pitchFamily="34" charset="-122"/>
-                <a:cs typeface="微软雅黑" pitchFamily="34" charset="-120"/>
-              </a:rPr>
-              <a:t>可复用成果、能迁移到哪些场景。</a:t>
-            </a:r>
-            <a:endParaRPr lang="en-US" sz="1100" dirty="0"/>
-          </a:p>
-        </p:txBody>
-      </p:sp>
-      <p:sp>
-        <p:nvSpPr>
           <p:cNvPr id="29" name="Text 27"/>
           <p:cNvSpPr/>
           <p:nvPr/>
@@ -6333,47 +6128,6 @@
               <a:t>当前进展</a:t>
             </a:r>
             <a:endParaRPr lang="en-US" sz="1500" dirty="0"/>
-          </a:p>
-        </p:txBody>
-      </p:sp>
-      <p:sp>
-        <p:nvSpPr>
-          <p:cNvPr id="33" name="Text 31"/>
-          <p:cNvSpPr/>
-          <p:nvPr/>
-        </p:nvSpPr>
-        <p:spPr>
-          <a:xfrm>
-            <a:off x="8368589" y="4325112"/>
-            <a:ext cx="3027578" cy="548640"/>
-          </a:xfrm>
-          <a:prstGeom prst="rect">
-            <a:avLst/>
-          </a:prstGeom>
-          <a:noFill/>
-        </p:spPr>
-        <p:txBody>
-          <a:bodyPr wrap="square" lIns="0" tIns="0" rIns="0" bIns="0" rtlCol="0" anchor="t"/>
-          <a:lstStyle/>
-          <a:p>
-            <a:pPr marL="0" indent="0">
-              <a:lnSpc>
-                <a:spcPct val="115000"/>
-              </a:lnSpc>
-              <a:buNone/>
-            </a:pPr>
-            <a:r>
-              <a:rPr lang="en-US" sz="1100" dirty="0">
-                <a:solidFill>
-                  <a:srgbClr val="6B7280"/>
-                </a:solidFill>
-                <a:latin typeface="微软雅黑" pitchFamily="34" charset="0"/>
-                <a:ea typeface="微软雅黑" pitchFamily="34" charset="-122"/>
-                <a:cs typeface="微软雅黑" pitchFamily="34" charset="-120"/>
-              </a:rPr>
-              <a:t>做到了什么程度、有无可运行成果。</a:t>
-            </a:r>
-            <a:endParaRPr lang="en-US" sz="1100" dirty="0"/>
           </a:p>
         </p:txBody>
       </p:sp>
@@ -6504,6 +6258,10 @@
             <a:srgbClr val="2A2F5B"/>
           </a:solidFill>
         </p:spPr>
+        <p:txBody>
+          <a:bodyPr/>
+          <a:p/>
+        </p:txBody>
       </p:sp>
       <p:sp>
         <p:nvSpPr>
@@ -6523,6 +6281,10 @@
             <a:srgbClr val="2A2F5B"/>
           </a:solidFill>
         </p:spPr>
+        <p:txBody>
+          <a:bodyPr/>
+          <a:p/>
+        </p:txBody>
       </p:sp>
       <p:sp>
         <p:nvSpPr>
@@ -6589,6 +6351,10 @@
             <a:srgbClr val="2A2F5B"/>
           </a:solidFill>
         </p:spPr>
+        <p:txBody>
+          <a:bodyPr/>
+          <a:p/>
+        </p:txBody>
       </p:sp>
       <p:sp>
         <p:nvSpPr>
@@ -6610,6 +6376,10 @@
             <a:srgbClr val="FF6B35"/>
           </a:solidFill>
         </p:spPr>
+        <p:txBody>
+          <a:bodyPr/>
+          <a:p/>
+        </p:txBody>
       </p:sp>
       <p:sp>
         <p:nvSpPr>
@@ -6710,6 +6480,10 @@
             <a:srgbClr val="2A2F5B"/>
           </a:solidFill>
         </p:spPr>
+        <p:txBody>
+          <a:bodyPr/>
+          <a:p/>
+        </p:txBody>
       </p:sp>
       <p:sp>
         <p:nvSpPr>
@@ -6731,6 +6505,10 @@
             <a:srgbClr val="FF6B35"/>
           </a:solidFill>
         </p:spPr>
+        <p:txBody>
+          <a:bodyPr/>
+          <a:p/>
+        </p:txBody>
       </p:sp>
       <p:sp>
         <p:nvSpPr>
@@ -6830,6 +6608,10 @@
             <a:srgbClr val="2A2F5B"/>
           </a:solidFill>
         </p:spPr>
+        <p:txBody>
+          <a:bodyPr/>
+          <a:p/>
+        </p:txBody>
       </p:sp>
       <p:sp>
         <p:nvSpPr>
@@ -6851,6 +6633,10 @@
             <a:srgbClr val="FF6B35"/>
           </a:solidFill>
         </p:spPr>
+        <p:txBody>
+          <a:bodyPr/>
+          <a:p/>
+        </p:txBody>
       </p:sp>
       <p:sp>
         <p:nvSpPr>
@@ -6951,6 +6737,10 @@
             <a:srgbClr val="2A2F5B"/>
           </a:solidFill>
         </p:spPr>
+        <p:txBody>
+          <a:bodyPr/>
+          <a:p/>
+        </p:txBody>
       </p:sp>
       <p:sp>
         <p:nvSpPr>
@@ -6972,6 +6762,10 @@
             <a:srgbClr val="FF6B35"/>
           </a:solidFill>
         </p:spPr>
+        <p:txBody>
+          <a:bodyPr/>
+          <a:p/>
+        </p:txBody>
       </p:sp>
       <p:sp>
         <p:nvSpPr>
@@ -7103,6 +6897,10 @@
             <a:srgbClr val="FF6B35"/>
           </a:solidFill>
         </p:spPr>
+        <p:txBody>
+          <a:bodyPr/>
+          <a:p/>
+        </p:txBody>
       </p:sp>
       <p:sp>
         <p:nvSpPr>
@@ -7225,6 +7023,10 @@
             <a:srgbClr val="2A2F5B"/>
           </a:solidFill>
         </p:spPr>
+        <p:txBody>
+          <a:bodyPr/>
+          <a:p/>
+        </p:txBody>
       </p:sp>
       <p:sp>
         <p:nvSpPr>
@@ -7246,6 +7048,10 @@
             <a:srgbClr val="FF6B35"/>
           </a:solidFill>
         </p:spPr>
+        <p:txBody>
+          <a:bodyPr/>
+          <a:p/>
+        </p:txBody>
       </p:sp>
       <p:sp>
         <p:nvSpPr>
@@ -7345,6 +7151,10 @@
             <a:srgbClr val="2A2F5B"/>
           </a:solidFill>
         </p:spPr>
+        <p:txBody>
+          <a:bodyPr/>
+          <a:p/>
+        </p:txBody>
       </p:sp>
       <p:sp>
         <p:nvSpPr>
@@ -7366,6 +7176,10 @@
             <a:srgbClr val="FF6B35"/>
           </a:solidFill>
         </p:spPr>
+        <p:txBody>
+          <a:bodyPr/>
+          <a:p/>
+        </p:txBody>
       </p:sp>
       <p:sp>
         <p:nvSpPr>
@@ -7477,6 +7291,10 @@
             <a:srgbClr val="2A2F5B"/>
           </a:solidFill>
         </p:spPr>
+        <p:txBody>
+          <a:bodyPr/>
+          <a:p/>
+        </p:txBody>
       </p:sp>
       <p:sp>
         <p:nvSpPr>
@@ -7498,6 +7316,10 @@
             <a:srgbClr val="FF6B35"/>
           </a:solidFill>
         </p:spPr>
+        <p:txBody>
+          <a:bodyPr/>
+          <a:p/>
+        </p:txBody>
       </p:sp>
       <p:sp>
         <p:nvSpPr>
@@ -7565,7 +7387,7 @@
                 <a:ea typeface="微软雅黑" pitchFamily="34" charset="-122"/>
                 <a:cs typeface="微软雅黑" pitchFamily="34" charset="-120"/>
               </a:rPr>
-              <a:t>Demo</a:t>
+              <a:t>Demo 视频（复赛提交）</a:t>
             </a:r>
             <a:r>
               <a:rPr lang="zh-CN" altLang="en-US" sz="1250" dirty="0">
@@ -7576,7 +7398,7 @@
                 <a:ea typeface="微软雅黑" pitchFamily="34" charset="-122"/>
                 <a:cs typeface="微软雅黑" pitchFamily="34" charset="-120"/>
               </a:rPr>
-              <a:t>视频（如有</a:t>
+              <a:t/>
             </a:r>
             <a:r>
               <a:rPr lang="en-US" altLang="zh-CN" sz="1250" dirty="0">
@@ -7587,7 +7409,7 @@
                 <a:ea typeface="微软雅黑" pitchFamily="34" charset="-122"/>
                 <a:cs typeface="微软雅黑" pitchFamily="34" charset="-120"/>
               </a:rPr>
-              <a:t>）</a:t>
+              <a:t/>
             </a:r>
             <a:endParaRPr lang="en-US" altLang="zh-CN" sz="1250" dirty="0">
               <a:solidFill>
@@ -8033,44 +7855,6 @@
               <a:latin typeface="微软雅黑" pitchFamily="34" charset="0"/>
               <a:ea typeface="微软雅黑" pitchFamily="34" charset="0"/>
             </a:endParaRPr>
-          </a:p>
-        </p:txBody>
-      </p:sp>
-      <p:sp>
-        <p:nvSpPr>
-          <p:cNvPr id="7" name="文本框 6"/>
-          <p:cNvSpPr txBox="1"/>
-          <p:nvPr/>
-        </p:nvSpPr>
-        <p:spPr>
-          <a:xfrm>
-            <a:off x="3968115" y="5574030"/>
-            <a:ext cx="4064000" cy="368300"/>
-          </a:xfrm>
-          <a:prstGeom prst="rect">
-            <a:avLst/>
-          </a:prstGeom>
-          <a:noFill/>
-        </p:spPr>
-        <p:txBody>
-          <a:bodyPr wrap="square" rtlCol="0">
-            <a:spAutoFit/>
-          </a:bodyPr>
-          <a:p>
-            <a:pPr algn="ctr"/>
-            <a:r>
-              <a:rPr lang="en-US" altLang="zh-CN"/>
-              <a:t>（</a:t>
-            </a:r>
-            <a:r>
-              <a:rPr lang="zh-CN" altLang="en-US"/>
-              <a:t>示例</a:t>
-            </a:r>
-            <a:r>
-              <a:rPr lang="en-US" altLang="zh-CN"/>
-              <a:t>）</a:t>
-            </a:r>
-            <a:endParaRPr lang="en-US" altLang="zh-CN"/>
           </a:p>
         </p:txBody>
       </p:sp>

</xml_diff>